<commit_message>
Agrega el link de Vercel y el QR del esqueleto
- QR que abre https://cartaviva-ten.vercel.app en entregables/
- Nueva diapositiva "Míralo en tu celular" en la presentación
- Link del esqueleto y del repositorio en el README

Co-Authored-By: Claude Opus 5.5 <noreply@anthropic.com>
</commit_message>
<xml_diff>
--- a/entregables/Cartaviva_Presentacion.pptx
+++ b/entregables/Cartaviva_Presentacion.pptx
@@ -16,9 +16,10 @@
     <p:sldId id="264" r:id="rId10"/>
     <p:sldId id="265" r:id="rId11"/>
     <p:sldId id="266" r:id="rId12"/>
+    <p:sldId id="267" r:id="rId13"/>
   </p:sldIdLst>
   <p:notesMasterIdLst>
-    <p:notesMasterId r:id="rId13"/>
+    <p:notesMasterId r:id="rId14"/>
   </p:notesMasterIdLst>
   <p:sldSz cx="12192000" cy="6858000"/>
   <p:notesSz cx="6858000" cy="12192000"/>
@@ -117,31 +118,32 @@
   <p:extLst>
     <p:ext uri="{521415D9-36F7-43E2-AB2F-B90AF26B5E84}">
       <p14:sectionLst xmlns:p14="http://schemas.microsoft.com/office/powerpoint/2010/main">
-        <p14:section name="Problema y evidencias" id="{a9afa1cb-02e2-a540-78ea-dcdf7dbc1170}">
+        <p14:section name="Problema y evidencias" id="{6f4b5308-a54b-7be4-7350-6584c569fbe5}">
           <p14:sldIdLst>
             <p14:sldId id="256"/>
             <p14:sldId id="257"/>
             <p14:sldId id="258"/>
           </p14:sldIdLst>
         </p14:section>
-        <p14:section name="Qué vamos a construir" id="{f6315e84-603d-9f5a-2bea-4676462826da}">
+        <p14:section name="Qué vamos a construir" id="{05b90cc0-de10-fa76-4c24-4b0ac7318cc0}">
           <p14:sldIdLst>
             <p14:sldId id="259"/>
             <p14:sldId id="260"/>
             <p14:sldId id="261"/>
           </p14:sldIdLst>
         </p14:section>
-        <p14:section name="Esqueleto e identidad" id="{72b6e0f4-e8df-ded3-9286-99a0ddd6dab6}">
+        <p14:section name="Esqueleto e identidad" id="{bffd16c4-8901-d595-e5fe-957f1a61336f}">
           <p14:sldIdLst>
             <p14:sldId id="262"/>
             <p14:sldId id="263"/>
             <p14:sldId id="264"/>
+            <p14:sldId id="265"/>
           </p14:sldIdLst>
         </p14:section>
-        <p14:section name="Cómo lo trabajamos" id="{ef9d4247-e641-1a70-76e7-cf2c2ac1f55b}">
+        <p14:section name="Cómo lo trabajamos" id="{a28d8238-7323-563a-ac8a-feec98907529}">
           <p14:sldIdLst>
-            <p14:sldId id="265"/>
             <p14:sldId id="266"/>
+            <p14:sldId id="267"/>
           </p14:sldIdLst>
         </p14:section>
       </p14:sectionLst>
@@ -636,7 +638,7 @@
           <a:p>
             <a:r>
               <a:rPr lang="en-US" dirty="0"/>
-              <a:t>Usamos desarrollo incremental basado en un MVP, como pide la guía de Aplicaciones Web II. Son cinco fases y cada una termina con algo que se puede mostrar funcionando. El trabajo de Diseño Web, que es este entregable, alimenta la fase 1: el esqueleto se convierte en las plantillas HTML de Django. Cada integrante hace sus propios commits para que la participación quede verificable.</a:t>
+              <a:t>La paleta sale de la ciudad: el azul del mar Caribe para las acciones principales, el amarillo del sol para destacar planes relámpago y últimos cupos, el azul oscuro colonial para el texto y el blanco arena de fondo. Las cuatro reglas de abajo son las que seguimos en todas las pantallas: diseño primero para celular porque en Cartagena casi todos se conectan desde el móvil, contraste accesible, animaciones cortas que dan respuesta inmediata, y una forma consistente.</a:t>
             </a:r>
             <a:endParaRPr lang="en-US" dirty="0"/>
           </a:p>
@@ -724,7 +726,7 @@
           <a:p>
             <a:r>
               <a:rPr lang="en-US" dirty="0"/>
-              <a:t>Cerrar respondiendo la pregunta de control con las tres evidencias. Luego decir qué se entrega hoy: la ficha, el esqueleto publicado en Vercel, el MVP funcionando en Django y esta presentación. Y cuál es el siguiente paso: recoger evidencia propia con la encuesta y las entrevistas, y conectar el MVP a MySQL para desplegarlo. Abrir preguntas.</a:t>
+              <a:t>Usamos desarrollo incremental basado en un MVP, como pide la guía de Aplicaciones Web II. Son cinco fases y cada una termina con algo que se puede mostrar funcionando. El trabajo de Diseño Web, que es este entregable, alimenta la fase 1: el esqueleto se convierte en las plantillas HTML de Django. Cada integrante hace sus propios commits para que la participación quede verificable.</a:t>
             </a:r>
             <a:endParaRPr lang="en-US" dirty="0"/>
           </a:p>
@@ -748,6 +750,94 @@
             <a:fld id="{F7021451-1387-4CA6-816F-3879F97B5CBC}" type="slidenum">
               <a:rPr lang="en-US"/>
               <a:t>11</a:t>
+            </a:fld>
+            <a:endParaRPr lang="en-US"/>
+          </a:p>
+        </p:txBody>
+      </p:sp>
+    </p:spTree>
+    <p:extLst>
+      <p:ext uri="{BB962C8B-B14F-4D97-AF65-F5344CB8AC3E}">
+        <p14:creationId xmlns:p14="http://schemas.microsoft.com/office/powerpoint/2010/main" val="1024086991"/>
+      </p:ext>
+    </p:extLst>
+  </p:cSld>
+  <p:clrMapOvr>
+    <a:masterClrMapping/>
+  </p:clrMapOvr>
+</p:notes>
+</file>
+
+<file path=ppt/notesSlides/notesSlide12.xml><?xml version="1.0" encoding="utf-8"?>
+<p:notes xmlns:a="http://schemas.openxmlformats.org/drawingml/2006/main" xmlns:r="http://schemas.openxmlformats.org/officeDocument/2006/relationships" xmlns:p="http://schemas.openxmlformats.org/presentationml/2006/main">
+  <p:cSld>
+    <p:spTree>
+      <p:nvGrpSpPr>
+        <p:cNvPr id="1" name=""/>
+        <p:cNvGrpSpPr/>
+        <p:nvPr/>
+      </p:nvGrpSpPr>
+      <p:grpSpPr>
+        <a:xfrm>
+          <a:off x="0" y="0"/>
+          <a:ext cx="0" cy="0"/>
+          <a:chOff x="0" y="0"/>
+          <a:chExt cx="0" cy="0"/>
+        </a:xfrm>
+      </p:grpSpPr>
+      <p:sp>
+        <p:nvSpPr>
+          <p:cNvPr id="2" name="Slide Image Placeholder 1"/>
+          <p:cNvSpPr>
+            <a:spLocks noGrp="1" noRot="1" noChangeAspect="1"/>
+          </p:cNvSpPr>
+          <p:nvPr>
+            <p:ph type="sldImg"/>
+          </p:nvPr>
+        </p:nvSpPr>
+        <p:spPr/>
+      </p:sp>
+      <p:sp>
+        <p:nvSpPr>
+          <p:cNvPr id="3" name="Notes Placeholder 2"/>
+          <p:cNvSpPr>
+            <a:spLocks noGrp="1"/>
+          </p:cNvSpPr>
+          <p:nvPr>
+            <p:ph type="body" idx="1"/>
+          </p:nvPr>
+        </p:nvSpPr>
+        <p:spPr/>
+        <p:txBody>
+          <a:bodyPr/>
+          <a:lstStyle/>
+          <a:p>
+            <a:r>
+              <a:rPr lang="en-US" dirty="0"/>
+              <a:t>Cerrar respondiendo la pregunta de control con las tres evidencias. Luego decir qué se entrega hoy: la ficha, el esqueleto publicado en Vercel, el MVP funcionando en Django y esta presentación. Y cuál es el siguiente paso: recoger evidencia propia con la encuesta y las entrevistas, y conectar el MVP a MySQL para desplegarlo. Abrir preguntas.</a:t>
+            </a:r>
+            <a:endParaRPr lang="en-US" dirty="0"/>
+          </a:p>
+        </p:txBody>
+      </p:sp>
+      <p:sp>
+        <p:nvSpPr>
+          <p:cNvPr id="4" name="Slide Number Placeholder 3"/>
+          <p:cNvSpPr>
+            <a:spLocks noGrp="1"/>
+          </p:cNvSpPr>
+          <p:nvPr>
+            <p:ph type="sldNum" sz="quarter" idx="10"/>
+          </p:nvPr>
+        </p:nvSpPr>
+        <p:spPr/>
+        <p:txBody>
+          <a:bodyPr/>
+          <a:lstStyle/>
+          <a:p>
+            <a:fld id="{F7021451-1387-4CA6-816F-3879F97B5CBC}" type="slidenum">
+              <a:rPr lang="en-US"/>
+              <a:t>12</a:t>
             </a:fld>
             <a:endParaRPr lang="en-US"/>
           </a:p>
@@ -1428,7 +1518,7 @@
           <a:p>
             <a:r>
               <a:rPr lang="en-US" dirty="0"/>
-              <a:t>La paleta sale de la ciudad: el azul del mar Caribe para las acciones principales, el amarillo del sol para destacar planes relámpago y últimos cupos, el azul oscuro colonial para el texto y el blanco arena de fondo. Las cuatro reglas de abajo son las que seguimos en todas las pantallas: diseño primero para celular porque en Cartagena casi todos se conectan desde el móvil, contraste accesible, animaciones cortas que dan respuesta inmediata, y una forma consistente.</a:t>
+              <a:t>Pedirle a la profesora y a los compañeros que saquen el celular y escaneen el código. Abre la portada del esqueleto publicada en Vercel, con las seis pantallas. Mientras navegan, explicar que es mobile-first y que los textos entre corchetes son datos que vendrán de la base de datos. Si alguien no puede escanear, el link es cartaviva-ten.vercel.app.</a:t>
             </a:r>
             <a:endParaRPr lang="en-US" dirty="0"/>
           </a:p>
@@ -2087,6 +2177,984 @@
     <p:bg>
       <p:bgPr>
         <a:solidFill>
+          <a:srgbClr val="F8F9FA"/>
+        </a:solidFill>
+      </p:bgPr>
+    </p:bg>
+    <p:spTree>
+      <p:nvGrpSpPr>
+        <p:cNvPr id="1" name=""/>
+        <p:cNvGrpSpPr/>
+        <p:nvPr/>
+      </p:nvGrpSpPr>
+      <p:grpSpPr>
+        <a:xfrm>
+          <a:off x="0" y="0"/>
+          <a:ext cx="0" cy="0"/>
+          <a:chOff x="0" y="0"/>
+          <a:chExt cx="0" cy="0"/>
+        </a:xfrm>
+      </p:grpSpPr>
+      <p:sp>
+        <p:nvSpPr>
+          <p:cNvPr id="2" name="Text 0"/>
+          <p:cNvSpPr txBox="1"/>
+          <p:nvPr/>
+        </p:nvSpPr>
+        <p:spPr>
+          <a:xfrm>
+            <a:off x="548640" y="411480"/>
+            <a:ext cx="11094415" cy="274320"/>
+          </a:xfrm>
+          <a:prstGeom prst="rect">
+            <a:avLst/>
+          </a:prstGeom>
+          <a:noFill/>
+          <a:ln/>
+        </p:spPr>
+        <p:txBody>
+          <a:bodyPr wrap="square" lIns="0" tIns="0" rIns="0" bIns="0" rtlCol="0" anchor="t"/>
+          <a:lstStyle/>
+          <a:p>
+            <a:pPr indent="0" marL="0">
+              <a:buNone/>
+            </a:pPr>
+            <a:r>
+              <a:rPr lang="en-US" sz="1200" b="1" spc="200" kern="0" dirty="0">
+                <a:solidFill>
+                  <a:srgbClr val="0077B6"/>
+                </a:solidFill>
+                <a:latin typeface="Calibri" pitchFamily="34" charset="0"/>
+                <a:ea typeface="Calibri" pitchFamily="34" charset="-122"/>
+                <a:cs typeface="Calibri" pitchFamily="34" charset="-120"/>
+              </a:rPr>
+              <a:t>IDENTIDAD VISUAL</a:t>
+            </a:r>
+            <a:endParaRPr lang="en-US" sz="1200" dirty="0"/>
+          </a:p>
+        </p:txBody>
+      </p:sp>
+      <p:sp>
+        <p:nvSpPr>
+          <p:cNvPr id="3" name="Text 1"/>
+          <p:cNvSpPr txBox="1"/>
+          <p:nvPr/>
+        </p:nvSpPr>
+        <p:spPr>
+          <a:xfrm>
+            <a:off x="548640" y="731520"/>
+            <a:ext cx="11094415" cy="914400"/>
+          </a:xfrm>
+          <a:prstGeom prst="rect">
+            <a:avLst/>
+          </a:prstGeom>
+          <a:noFill/>
+          <a:ln/>
+        </p:spPr>
+        <p:txBody>
+          <a:bodyPr wrap="square" lIns="0" tIns="0" rIns="0" bIns="0" rtlCol="0" anchor="t"/>
+          <a:lstStyle/>
+          <a:p>
+            <a:pPr indent="0" marL="0">
+              <a:buNone/>
+            </a:pPr>
+            <a:r>
+              <a:rPr lang="en-US" sz="3200" b="1" dirty="0">
+                <a:solidFill>
+                  <a:srgbClr val="1D3557"/>
+                </a:solidFill>
+                <a:latin typeface="Calibri" pitchFamily="34" charset="0"/>
+                <a:ea typeface="Calibri" pitchFamily="34" charset="-122"/>
+                <a:cs typeface="Calibri" pitchFamily="34" charset="-120"/>
+              </a:rPr>
+              <a:t>Colores de Cartagena, pensada para el celular</a:t>
+            </a:r>
+            <a:endParaRPr lang="en-US" sz="3200" dirty="0"/>
+          </a:p>
+        </p:txBody>
+      </p:sp>
+      <p:sp>
+        <p:nvSpPr>
+          <p:cNvPr id="4" name="color-1"/>
+          <p:cNvSpPr/>
+          <p:nvPr/>
+        </p:nvSpPr>
+        <p:spPr>
+          <a:xfrm>
+            <a:off x="548640" y="1828800"/>
+            <a:ext cx="2567864" cy="1188720"/>
+          </a:xfrm>
+          <a:prstGeom prst="roundRect">
+            <a:avLst>
+              <a:gd name="adj" fmla="val 9231"/>
+            </a:avLst>
+          </a:prstGeom>
+          <a:solidFill>
+            <a:srgbClr val="0077B6"/>
+          </a:solidFill>
+          <a:ln w="12700">
+            <a:solidFill>
+              <a:srgbClr val="0077B6"/>
+            </a:solidFill>
+            <a:prstDash val="solid"/>
+          </a:ln>
+        </p:spPr>
+      </p:sp>
+      <p:sp>
+        <p:nvSpPr>
+          <p:cNvPr id="5" name="Text 3"/>
+          <p:cNvSpPr txBox="1"/>
+          <p:nvPr/>
+        </p:nvSpPr>
+        <p:spPr>
+          <a:xfrm>
+            <a:off x="548640" y="3127248"/>
+            <a:ext cx="2567864" cy="365760"/>
+          </a:xfrm>
+          <a:prstGeom prst="rect">
+            <a:avLst/>
+          </a:prstGeom>
+          <a:noFill/>
+          <a:ln/>
+        </p:spPr>
+        <p:txBody>
+          <a:bodyPr wrap="square" lIns="0" tIns="0" rIns="0" bIns="0" rtlCol="0" anchor="t"/>
+          <a:lstStyle/>
+          <a:p>
+            <a:pPr indent="0" marL="0">
+              <a:buNone/>
+            </a:pPr>
+            <a:r>
+              <a:rPr lang="en-US" sz="1600" b="1" dirty="0">
+                <a:solidFill>
+                  <a:srgbClr val="1D3557"/>
+                </a:solidFill>
+                <a:latin typeface="Calibri" pitchFamily="34" charset="0"/>
+                <a:ea typeface="Calibri" pitchFamily="34" charset="-122"/>
+                <a:cs typeface="Calibri" pitchFamily="34" charset="-120"/>
+              </a:rPr>
+              <a:t>Azul Caribe</a:t>
+            </a:r>
+            <a:endParaRPr lang="en-US" sz="1600" dirty="0"/>
+          </a:p>
+        </p:txBody>
+      </p:sp>
+      <p:sp>
+        <p:nvSpPr>
+          <p:cNvPr id="6" name="Text 4"/>
+          <p:cNvSpPr txBox="1"/>
+          <p:nvPr/>
+        </p:nvSpPr>
+        <p:spPr>
+          <a:xfrm>
+            <a:off x="548640" y="3474720"/>
+            <a:ext cx="2567864" cy="320040"/>
+          </a:xfrm>
+          <a:prstGeom prst="rect">
+            <a:avLst/>
+          </a:prstGeom>
+          <a:noFill/>
+          <a:ln/>
+        </p:spPr>
+        <p:txBody>
+          <a:bodyPr wrap="square" lIns="0" tIns="0" rIns="0" bIns="0" rtlCol="0" anchor="t"/>
+          <a:lstStyle/>
+          <a:p>
+            <a:pPr indent="0" marL="0">
+              <a:buNone/>
+            </a:pPr>
+            <a:r>
+              <a:rPr lang="en-US" sz="1200" dirty="0">
+                <a:solidFill>
+                  <a:srgbClr val="4A5B70"/>
+                </a:solidFill>
+                <a:latin typeface="Calibri" pitchFamily="34" charset="0"/>
+                <a:ea typeface="Calibri" pitchFamily="34" charset="-122"/>
+                <a:cs typeface="Calibri" pitchFamily="34" charset="-120"/>
+              </a:rPr>
+              <a:t>#0077B6 · acciones</a:t>
+            </a:r>
+            <a:endParaRPr lang="en-US" sz="1200" dirty="0"/>
+          </a:p>
+        </p:txBody>
+      </p:sp>
+      <p:sp>
+        <p:nvSpPr>
+          <p:cNvPr id="7" name="color-2"/>
+          <p:cNvSpPr/>
+          <p:nvPr/>
+        </p:nvSpPr>
+        <p:spPr>
+          <a:xfrm>
+            <a:off x="3390824" y="1828800"/>
+            <a:ext cx="2567864" cy="1188720"/>
+          </a:xfrm>
+          <a:prstGeom prst="roundRect">
+            <a:avLst>
+              <a:gd name="adj" fmla="val 9231"/>
+            </a:avLst>
+          </a:prstGeom>
+          <a:solidFill>
+            <a:srgbClr val="F77F00"/>
+          </a:solidFill>
+          <a:ln w="12700">
+            <a:solidFill>
+              <a:srgbClr val="F77F00"/>
+            </a:solidFill>
+            <a:prstDash val="solid"/>
+          </a:ln>
+        </p:spPr>
+      </p:sp>
+      <p:sp>
+        <p:nvSpPr>
+          <p:cNvPr id="8" name="Text 6"/>
+          <p:cNvSpPr txBox="1"/>
+          <p:nvPr/>
+        </p:nvSpPr>
+        <p:spPr>
+          <a:xfrm>
+            <a:off x="3390824" y="3127248"/>
+            <a:ext cx="2567864" cy="365760"/>
+          </a:xfrm>
+          <a:prstGeom prst="rect">
+            <a:avLst/>
+          </a:prstGeom>
+          <a:noFill/>
+          <a:ln/>
+        </p:spPr>
+        <p:txBody>
+          <a:bodyPr wrap="square" lIns="0" tIns="0" rIns="0" bIns="0" rtlCol="0" anchor="t"/>
+          <a:lstStyle/>
+          <a:p>
+            <a:pPr indent="0" marL="0">
+              <a:buNone/>
+            </a:pPr>
+            <a:r>
+              <a:rPr lang="en-US" sz="1600" b="1" dirty="0">
+                <a:solidFill>
+                  <a:srgbClr val="1D3557"/>
+                </a:solidFill>
+                <a:latin typeface="Calibri" pitchFamily="34" charset="0"/>
+                <a:ea typeface="Calibri" pitchFamily="34" charset="-122"/>
+                <a:cs typeface="Calibri" pitchFamily="34" charset="-120"/>
+              </a:rPr>
+              <a:t>Amarillo Sol</a:t>
+            </a:r>
+            <a:endParaRPr lang="en-US" sz="1600" dirty="0"/>
+          </a:p>
+        </p:txBody>
+      </p:sp>
+      <p:sp>
+        <p:nvSpPr>
+          <p:cNvPr id="9" name="Text 7"/>
+          <p:cNvSpPr txBox="1"/>
+          <p:nvPr/>
+        </p:nvSpPr>
+        <p:spPr>
+          <a:xfrm>
+            <a:off x="3390824" y="3474720"/>
+            <a:ext cx="2567864" cy="320040"/>
+          </a:xfrm>
+          <a:prstGeom prst="rect">
+            <a:avLst/>
+          </a:prstGeom>
+          <a:noFill/>
+          <a:ln/>
+        </p:spPr>
+        <p:txBody>
+          <a:bodyPr wrap="square" lIns="0" tIns="0" rIns="0" bIns="0" rtlCol="0" anchor="t"/>
+          <a:lstStyle/>
+          <a:p>
+            <a:pPr indent="0" marL="0">
+              <a:buNone/>
+            </a:pPr>
+            <a:r>
+              <a:rPr lang="en-US" sz="1200" dirty="0">
+                <a:solidFill>
+                  <a:srgbClr val="4A5B70"/>
+                </a:solidFill>
+                <a:latin typeface="Calibri" pitchFamily="34" charset="0"/>
+                <a:ea typeface="Calibri" pitchFamily="34" charset="-122"/>
+                <a:cs typeface="Calibri" pitchFamily="34" charset="-120"/>
+              </a:rPr>
+              <a:t>#F77F00 · destacados</a:t>
+            </a:r>
+            <a:endParaRPr lang="en-US" sz="1200" dirty="0"/>
+          </a:p>
+        </p:txBody>
+      </p:sp>
+      <p:sp>
+        <p:nvSpPr>
+          <p:cNvPr id="10" name="color-3"/>
+          <p:cNvSpPr/>
+          <p:nvPr/>
+        </p:nvSpPr>
+        <p:spPr>
+          <a:xfrm>
+            <a:off x="6233008" y="1828800"/>
+            <a:ext cx="2567864" cy="1188720"/>
+          </a:xfrm>
+          <a:prstGeom prst="roundRect">
+            <a:avLst>
+              <a:gd name="adj" fmla="val 9231"/>
+            </a:avLst>
+          </a:prstGeom>
+          <a:solidFill>
+            <a:srgbClr val="1D3557"/>
+          </a:solidFill>
+          <a:ln w="12700">
+            <a:solidFill>
+              <a:srgbClr val="1D3557"/>
+            </a:solidFill>
+            <a:prstDash val="solid"/>
+          </a:ln>
+        </p:spPr>
+      </p:sp>
+      <p:sp>
+        <p:nvSpPr>
+          <p:cNvPr id="11" name="Text 9"/>
+          <p:cNvSpPr txBox="1"/>
+          <p:nvPr/>
+        </p:nvSpPr>
+        <p:spPr>
+          <a:xfrm>
+            <a:off x="6233008" y="3127248"/>
+            <a:ext cx="2567864" cy="365760"/>
+          </a:xfrm>
+          <a:prstGeom prst="rect">
+            <a:avLst/>
+          </a:prstGeom>
+          <a:noFill/>
+          <a:ln/>
+        </p:spPr>
+        <p:txBody>
+          <a:bodyPr wrap="square" lIns="0" tIns="0" rIns="0" bIns="0" rtlCol="0" anchor="t"/>
+          <a:lstStyle/>
+          <a:p>
+            <a:pPr indent="0" marL="0">
+              <a:buNone/>
+            </a:pPr>
+            <a:r>
+              <a:rPr lang="en-US" sz="1600" b="1" dirty="0">
+                <a:solidFill>
+                  <a:srgbClr val="1D3557"/>
+                </a:solidFill>
+                <a:latin typeface="Calibri" pitchFamily="34" charset="0"/>
+                <a:ea typeface="Calibri" pitchFamily="34" charset="-122"/>
+                <a:cs typeface="Calibri" pitchFamily="34" charset="-120"/>
+              </a:rPr>
+              <a:t>Colonial Dark</a:t>
+            </a:r>
+            <a:endParaRPr lang="en-US" sz="1600" dirty="0"/>
+          </a:p>
+        </p:txBody>
+      </p:sp>
+      <p:sp>
+        <p:nvSpPr>
+          <p:cNvPr id="12" name="Text 10"/>
+          <p:cNvSpPr txBox="1"/>
+          <p:nvPr/>
+        </p:nvSpPr>
+        <p:spPr>
+          <a:xfrm>
+            <a:off x="6233008" y="3474720"/>
+            <a:ext cx="2567864" cy="320040"/>
+          </a:xfrm>
+          <a:prstGeom prst="rect">
+            <a:avLst/>
+          </a:prstGeom>
+          <a:noFill/>
+          <a:ln/>
+        </p:spPr>
+        <p:txBody>
+          <a:bodyPr wrap="square" lIns="0" tIns="0" rIns="0" bIns="0" rtlCol="0" anchor="t"/>
+          <a:lstStyle/>
+          <a:p>
+            <a:pPr indent="0" marL="0">
+              <a:buNone/>
+            </a:pPr>
+            <a:r>
+              <a:rPr lang="en-US" sz="1200" dirty="0">
+                <a:solidFill>
+                  <a:srgbClr val="4A5B70"/>
+                </a:solidFill>
+                <a:latin typeface="Calibri" pitchFamily="34" charset="0"/>
+                <a:ea typeface="Calibri" pitchFamily="34" charset="-122"/>
+                <a:cs typeface="Calibri" pitchFamily="34" charset="-120"/>
+              </a:rPr>
+              <a:t>#1D3557 · texto</a:t>
+            </a:r>
+            <a:endParaRPr lang="en-US" sz="1200" dirty="0"/>
+          </a:p>
+        </p:txBody>
+      </p:sp>
+      <p:sp>
+        <p:nvSpPr>
+          <p:cNvPr id="13" name="color-4"/>
+          <p:cNvSpPr/>
+          <p:nvPr/>
+        </p:nvSpPr>
+        <p:spPr>
+          <a:xfrm>
+            <a:off x="9075191" y="1828800"/>
+            <a:ext cx="2567864" cy="1188720"/>
+          </a:xfrm>
+          <a:prstGeom prst="roundRect">
+            <a:avLst>
+              <a:gd name="adj" fmla="val 9231"/>
+            </a:avLst>
+          </a:prstGeom>
+          <a:solidFill>
+            <a:srgbClr val="F8F9FA"/>
+          </a:solidFill>
+          <a:ln w="12700">
+            <a:solidFill>
+              <a:srgbClr val="C9D4DF"/>
+            </a:solidFill>
+            <a:prstDash val="solid"/>
+          </a:ln>
+        </p:spPr>
+      </p:sp>
+      <p:sp>
+        <p:nvSpPr>
+          <p:cNvPr id="14" name="Text 12"/>
+          <p:cNvSpPr txBox="1"/>
+          <p:nvPr/>
+        </p:nvSpPr>
+        <p:spPr>
+          <a:xfrm>
+            <a:off x="9075191" y="3127248"/>
+            <a:ext cx="2567864" cy="365760"/>
+          </a:xfrm>
+          <a:prstGeom prst="rect">
+            <a:avLst/>
+          </a:prstGeom>
+          <a:noFill/>
+          <a:ln/>
+        </p:spPr>
+        <p:txBody>
+          <a:bodyPr wrap="square" lIns="0" tIns="0" rIns="0" bIns="0" rtlCol="0" anchor="t"/>
+          <a:lstStyle/>
+          <a:p>
+            <a:pPr indent="0" marL="0">
+              <a:buNone/>
+            </a:pPr>
+            <a:r>
+              <a:rPr lang="en-US" sz="1600" b="1" dirty="0">
+                <a:solidFill>
+                  <a:srgbClr val="1D3557"/>
+                </a:solidFill>
+                <a:latin typeface="Calibri" pitchFamily="34" charset="0"/>
+                <a:ea typeface="Calibri" pitchFamily="34" charset="-122"/>
+                <a:cs typeface="Calibri" pitchFamily="34" charset="-120"/>
+              </a:rPr>
+              <a:t>Blanco Arena</a:t>
+            </a:r>
+            <a:endParaRPr lang="en-US" sz="1600" dirty="0"/>
+          </a:p>
+        </p:txBody>
+      </p:sp>
+      <p:sp>
+        <p:nvSpPr>
+          <p:cNvPr id="15" name="Text 13"/>
+          <p:cNvSpPr txBox="1"/>
+          <p:nvPr/>
+        </p:nvSpPr>
+        <p:spPr>
+          <a:xfrm>
+            <a:off x="9075191" y="3474720"/>
+            <a:ext cx="2567864" cy="320040"/>
+          </a:xfrm>
+          <a:prstGeom prst="rect">
+            <a:avLst/>
+          </a:prstGeom>
+          <a:noFill/>
+          <a:ln/>
+        </p:spPr>
+        <p:txBody>
+          <a:bodyPr wrap="square" lIns="0" tIns="0" rIns="0" bIns="0" rtlCol="0" anchor="t"/>
+          <a:lstStyle/>
+          <a:p>
+            <a:pPr indent="0" marL="0">
+              <a:buNone/>
+            </a:pPr>
+            <a:r>
+              <a:rPr lang="en-US" sz="1200" dirty="0">
+                <a:solidFill>
+                  <a:srgbClr val="4A5B70"/>
+                </a:solidFill>
+                <a:latin typeface="Calibri" pitchFamily="34" charset="0"/>
+                <a:ea typeface="Calibri" pitchFamily="34" charset="-122"/>
+                <a:cs typeface="Calibri" pitchFamily="34" charset="-120"/>
+              </a:rPr>
+              <a:t>#F8F9FA · fondo</a:t>
+            </a:r>
+            <a:endParaRPr lang="en-US" sz="1200" dirty="0"/>
+          </a:p>
+        </p:txBody>
+      </p:sp>
+      <p:sp>
+        <p:nvSpPr>
+          <p:cNvPr id="16" name="regla-1"/>
+          <p:cNvSpPr/>
+          <p:nvPr/>
+        </p:nvSpPr>
+        <p:spPr>
+          <a:xfrm>
+            <a:off x="548640" y="4160520"/>
+            <a:ext cx="2567864" cy="2011680"/>
+          </a:xfrm>
+          <a:prstGeom prst="roundRect">
+            <a:avLst>
+              <a:gd name="adj" fmla="val 5455"/>
+            </a:avLst>
+          </a:prstGeom>
+          <a:solidFill>
+            <a:srgbClr val="FFFFFF"/>
+          </a:solidFill>
+          <a:ln w="12700">
+            <a:solidFill>
+              <a:srgbClr val="FFFFFF"/>
+            </a:solidFill>
+            <a:prstDash val="solid"/>
+          </a:ln>
+          <a:effectLst>
+            <a:outerShdw sx="100000" sy="100000" kx="0" ky="0" algn="bl" rotWithShape="0" blurRad="101600" dist="25400" dir="5400000">
+              <a:srgbClr val="1D3557">
+                <a:alpha val="12000"/>
+              </a:srgbClr>
+            </a:outerShdw>
+          </a:effectLst>
+        </p:spPr>
+      </p:sp>
+      <p:sp>
+        <p:nvSpPr>
+          <p:cNvPr id="17" name="Text 15"/>
+          <p:cNvSpPr txBox="1"/>
+          <p:nvPr/>
+        </p:nvSpPr>
+        <p:spPr>
+          <a:xfrm>
+            <a:off x="822960" y="4389120"/>
+            <a:ext cx="2019224" cy="411480"/>
+          </a:xfrm>
+          <a:prstGeom prst="rect">
+            <a:avLst/>
+          </a:prstGeom>
+          <a:noFill/>
+          <a:ln/>
+        </p:spPr>
+        <p:txBody>
+          <a:bodyPr wrap="square" lIns="0" tIns="0" rIns="0" bIns="0" rtlCol="0" anchor="t"/>
+          <a:lstStyle/>
+          <a:p>
+            <a:pPr indent="0" marL="0">
+              <a:buNone/>
+            </a:pPr>
+            <a:r>
+              <a:rPr lang="en-US" sz="1800" b="1" dirty="0">
+                <a:solidFill>
+                  <a:srgbClr val="1D3557"/>
+                </a:solidFill>
+                <a:latin typeface="Calibri" pitchFamily="34" charset="0"/>
+                <a:ea typeface="Calibri" pitchFamily="34" charset="-122"/>
+                <a:cs typeface="Calibri" pitchFamily="34" charset="-120"/>
+              </a:rPr>
+              <a:t>Mobile-first</a:t>
+            </a:r>
+            <a:endParaRPr lang="en-US" sz="1800" dirty="0"/>
+          </a:p>
+        </p:txBody>
+      </p:sp>
+      <p:sp>
+        <p:nvSpPr>
+          <p:cNvPr id="18" name="Text 16"/>
+          <p:cNvSpPr txBox="1"/>
+          <p:nvPr/>
+        </p:nvSpPr>
+        <p:spPr>
+          <a:xfrm>
+            <a:off x="822960" y="4846320"/>
+            <a:ext cx="2019224" cy="1188720"/>
+          </a:xfrm>
+          <a:prstGeom prst="rect">
+            <a:avLst/>
+          </a:prstGeom>
+          <a:noFill/>
+          <a:ln/>
+        </p:spPr>
+        <p:txBody>
+          <a:bodyPr wrap="square" lIns="0" tIns="0" rIns="0" bIns="0" rtlCol="0" anchor="t"/>
+          <a:lstStyle/>
+          <a:p>
+            <a:pPr indent="0" marL="0">
+              <a:buNone/>
+            </a:pPr>
+            <a:r>
+              <a:rPr lang="en-US" sz="1400" dirty="0">
+                <a:solidFill>
+                  <a:srgbClr val="3E5068"/>
+                </a:solidFill>
+                <a:latin typeface="Calibri" pitchFamily="34" charset="0"/>
+                <a:ea typeface="Calibri" pitchFamily="34" charset="-122"/>
+                <a:cs typeface="Calibri" pitchFamily="34" charset="-120"/>
+              </a:rPr>
+              <a:t>Pantallas de 390 px; botones de 44 px o más.</a:t>
+            </a:r>
+            <a:endParaRPr lang="en-US" sz="1400" dirty="0"/>
+          </a:p>
+        </p:txBody>
+      </p:sp>
+      <p:sp>
+        <p:nvSpPr>
+          <p:cNvPr id="19" name="regla-2"/>
+          <p:cNvSpPr/>
+          <p:nvPr/>
+        </p:nvSpPr>
+        <p:spPr>
+          <a:xfrm>
+            <a:off x="3390824" y="4160520"/>
+            <a:ext cx="2567864" cy="2011680"/>
+          </a:xfrm>
+          <a:prstGeom prst="roundRect">
+            <a:avLst>
+              <a:gd name="adj" fmla="val 5455"/>
+            </a:avLst>
+          </a:prstGeom>
+          <a:solidFill>
+            <a:srgbClr val="FFFFFF"/>
+          </a:solidFill>
+          <a:ln w="12700">
+            <a:solidFill>
+              <a:srgbClr val="FFFFFF"/>
+            </a:solidFill>
+            <a:prstDash val="solid"/>
+          </a:ln>
+          <a:effectLst>
+            <a:outerShdw sx="100000" sy="100000" kx="0" ky="0" algn="bl" rotWithShape="0" blurRad="101600" dist="25400" dir="5400000">
+              <a:srgbClr val="1D3557">
+                <a:alpha val="12000"/>
+              </a:srgbClr>
+            </a:outerShdw>
+          </a:effectLst>
+        </p:spPr>
+      </p:sp>
+      <p:sp>
+        <p:nvSpPr>
+          <p:cNvPr id="20" name="Text 18"/>
+          <p:cNvSpPr txBox="1"/>
+          <p:nvPr/>
+        </p:nvSpPr>
+        <p:spPr>
+          <a:xfrm>
+            <a:off x="3665144" y="4389120"/>
+            <a:ext cx="2019224" cy="411480"/>
+          </a:xfrm>
+          <a:prstGeom prst="rect">
+            <a:avLst/>
+          </a:prstGeom>
+          <a:noFill/>
+          <a:ln/>
+        </p:spPr>
+        <p:txBody>
+          <a:bodyPr wrap="square" lIns="0" tIns="0" rIns="0" bIns="0" rtlCol="0" anchor="t"/>
+          <a:lstStyle/>
+          <a:p>
+            <a:pPr indent="0" marL="0">
+              <a:buNone/>
+            </a:pPr>
+            <a:r>
+              <a:rPr lang="en-US" sz="1800" b="1" dirty="0">
+                <a:solidFill>
+                  <a:srgbClr val="1D3557"/>
+                </a:solidFill>
+                <a:latin typeface="Calibri" pitchFamily="34" charset="0"/>
+                <a:ea typeface="Calibri" pitchFamily="34" charset="-122"/>
+                <a:cs typeface="Calibri" pitchFamily="34" charset="-120"/>
+              </a:rPr>
+              <a:t>Contraste AA</a:t>
+            </a:r>
+            <a:endParaRPr lang="en-US" sz="1800" dirty="0"/>
+          </a:p>
+        </p:txBody>
+      </p:sp>
+      <p:sp>
+        <p:nvSpPr>
+          <p:cNvPr id="21" name="Text 19"/>
+          <p:cNvSpPr txBox="1"/>
+          <p:nvPr/>
+        </p:nvSpPr>
+        <p:spPr>
+          <a:xfrm>
+            <a:off x="3665144" y="4846320"/>
+            <a:ext cx="2019224" cy="1188720"/>
+          </a:xfrm>
+          <a:prstGeom prst="rect">
+            <a:avLst/>
+          </a:prstGeom>
+          <a:noFill/>
+          <a:ln/>
+        </p:spPr>
+        <p:txBody>
+          <a:bodyPr wrap="square" lIns="0" tIns="0" rIns="0" bIns="0" rtlCol="0" anchor="t"/>
+          <a:lstStyle/>
+          <a:p>
+            <a:pPr indent="0" marL="0">
+              <a:buNone/>
+            </a:pPr>
+            <a:r>
+              <a:rPr lang="en-US" sz="1400" dirty="0">
+                <a:solidFill>
+                  <a:srgbClr val="3E5068"/>
+                </a:solidFill>
+                <a:latin typeface="Calibri" pitchFamily="34" charset="0"/>
+                <a:ea typeface="Calibri" pitchFamily="34" charset="-122"/>
+                <a:cs typeface="Calibri" pitchFamily="34" charset="-120"/>
+              </a:rPr>
+              <a:t>Texto con 4,5:1 o más sobre su fondo (WCAG).</a:t>
+            </a:r>
+            <a:endParaRPr lang="en-US" sz="1400" dirty="0"/>
+          </a:p>
+        </p:txBody>
+      </p:sp>
+      <p:sp>
+        <p:nvSpPr>
+          <p:cNvPr id="22" name="regla-3"/>
+          <p:cNvSpPr/>
+          <p:nvPr/>
+        </p:nvSpPr>
+        <p:spPr>
+          <a:xfrm>
+            <a:off x="6233008" y="4160520"/>
+            <a:ext cx="2567864" cy="2011680"/>
+          </a:xfrm>
+          <a:prstGeom prst="roundRect">
+            <a:avLst>
+              <a:gd name="adj" fmla="val 5455"/>
+            </a:avLst>
+          </a:prstGeom>
+          <a:solidFill>
+            <a:srgbClr val="FFFFFF"/>
+          </a:solidFill>
+          <a:ln w="12700">
+            <a:solidFill>
+              <a:srgbClr val="FFFFFF"/>
+            </a:solidFill>
+            <a:prstDash val="solid"/>
+          </a:ln>
+          <a:effectLst>
+            <a:outerShdw sx="100000" sy="100000" kx="0" ky="0" algn="bl" rotWithShape="0" blurRad="101600" dist="25400" dir="5400000">
+              <a:srgbClr val="1D3557">
+                <a:alpha val="12000"/>
+              </a:srgbClr>
+            </a:outerShdw>
+          </a:effectLst>
+        </p:spPr>
+      </p:sp>
+      <p:sp>
+        <p:nvSpPr>
+          <p:cNvPr id="23" name="Text 21"/>
+          <p:cNvSpPr txBox="1"/>
+          <p:nvPr/>
+        </p:nvSpPr>
+        <p:spPr>
+          <a:xfrm>
+            <a:off x="6507328" y="4389120"/>
+            <a:ext cx="2019224" cy="411480"/>
+          </a:xfrm>
+          <a:prstGeom prst="rect">
+            <a:avLst/>
+          </a:prstGeom>
+          <a:noFill/>
+          <a:ln/>
+        </p:spPr>
+        <p:txBody>
+          <a:bodyPr wrap="square" lIns="0" tIns="0" rIns="0" bIns="0" rtlCol="0" anchor="t"/>
+          <a:lstStyle/>
+          <a:p>
+            <a:pPr indent="0" marL="0">
+              <a:buNone/>
+            </a:pPr>
+            <a:r>
+              <a:rPr lang="en-US" sz="1800" b="1" dirty="0">
+                <a:solidFill>
+                  <a:srgbClr val="1D3557"/>
+                </a:solidFill>
+                <a:latin typeface="Calibri" pitchFamily="34" charset="0"/>
+                <a:ea typeface="Calibri" pitchFamily="34" charset="-122"/>
+                <a:cs typeface="Calibri" pitchFamily="34" charset="-120"/>
+              </a:rPr>
+              <a:t>Movimiento</a:t>
+            </a:r>
+            <a:endParaRPr lang="en-US" sz="1800" dirty="0"/>
+          </a:p>
+        </p:txBody>
+      </p:sp>
+      <p:sp>
+        <p:nvSpPr>
+          <p:cNvPr id="24" name="Text 22"/>
+          <p:cNvSpPr txBox="1"/>
+          <p:nvPr/>
+        </p:nvSpPr>
+        <p:spPr>
+          <a:xfrm>
+            <a:off x="6507328" y="4846320"/>
+            <a:ext cx="2019224" cy="1188720"/>
+          </a:xfrm>
+          <a:prstGeom prst="rect">
+            <a:avLst/>
+          </a:prstGeom>
+          <a:noFill/>
+          <a:ln/>
+        </p:spPr>
+        <p:txBody>
+          <a:bodyPr wrap="square" lIns="0" tIns="0" rIns="0" bIns="0" rtlCol="0" anchor="t"/>
+          <a:lstStyle/>
+          <a:p>
+            <a:pPr indent="0" marL="0">
+              <a:buNone/>
+            </a:pPr>
+            <a:r>
+              <a:rPr lang="en-US" sz="1400" dirty="0">
+                <a:solidFill>
+                  <a:srgbClr val="3E5068"/>
+                </a:solidFill>
+                <a:latin typeface="Calibri" pitchFamily="34" charset="0"/>
+                <a:ea typeface="Calibri" pitchFamily="34" charset="-122"/>
+                <a:cs typeface="Calibri" pitchFamily="34" charset="-120"/>
+              </a:rPr>
+              <a:t>Transiciones de 200 a 300 ms y skeletons de carga.</a:t>
+            </a:r>
+            <a:endParaRPr lang="en-US" sz="1400" dirty="0"/>
+          </a:p>
+        </p:txBody>
+      </p:sp>
+      <p:sp>
+        <p:nvSpPr>
+          <p:cNvPr id="25" name="regla-4"/>
+          <p:cNvSpPr/>
+          <p:nvPr/>
+        </p:nvSpPr>
+        <p:spPr>
+          <a:xfrm>
+            <a:off x="9075191" y="4160520"/>
+            <a:ext cx="2567864" cy="2011680"/>
+          </a:xfrm>
+          <a:prstGeom prst="roundRect">
+            <a:avLst>
+              <a:gd name="adj" fmla="val 5455"/>
+            </a:avLst>
+          </a:prstGeom>
+          <a:solidFill>
+            <a:srgbClr val="FFFFFF"/>
+          </a:solidFill>
+          <a:ln w="12700">
+            <a:solidFill>
+              <a:srgbClr val="FFFFFF"/>
+            </a:solidFill>
+            <a:prstDash val="solid"/>
+          </a:ln>
+          <a:effectLst>
+            <a:outerShdw sx="100000" sy="100000" kx="0" ky="0" algn="bl" rotWithShape="0" blurRad="101600" dist="25400" dir="5400000">
+              <a:srgbClr val="1D3557">
+                <a:alpha val="12000"/>
+              </a:srgbClr>
+            </a:outerShdw>
+          </a:effectLst>
+        </p:spPr>
+      </p:sp>
+      <p:sp>
+        <p:nvSpPr>
+          <p:cNvPr id="26" name="Text 24"/>
+          <p:cNvSpPr txBox="1"/>
+          <p:nvPr/>
+        </p:nvSpPr>
+        <p:spPr>
+          <a:xfrm>
+            <a:off x="9349511" y="4389120"/>
+            <a:ext cx="2019224" cy="411480"/>
+          </a:xfrm>
+          <a:prstGeom prst="rect">
+            <a:avLst/>
+          </a:prstGeom>
+          <a:noFill/>
+          <a:ln/>
+        </p:spPr>
+        <p:txBody>
+          <a:bodyPr wrap="square" lIns="0" tIns="0" rIns="0" bIns="0" rtlCol="0" anchor="t"/>
+          <a:lstStyle/>
+          <a:p>
+            <a:pPr indent="0" marL="0">
+              <a:buNone/>
+            </a:pPr>
+            <a:r>
+              <a:rPr lang="en-US" sz="1800" b="1" dirty="0">
+                <a:solidFill>
+                  <a:srgbClr val="1D3557"/>
+                </a:solidFill>
+                <a:latin typeface="Calibri" pitchFamily="34" charset="0"/>
+                <a:ea typeface="Calibri" pitchFamily="34" charset="-122"/>
+                <a:cs typeface="Calibri" pitchFamily="34" charset="-120"/>
+              </a:rPr>
+              <a:t>Forma</a:t>
+            </a:r>
+            <a:endParaRPr lang="en-US" sz="1800" dirty="0"/>
+          </a:p>
+        </p:txBody>
+      </p:sp>
+      <p:sp>
+        <p:nvSpPr>
+          <p:cNvPr id="27" name="Text 25"/>
+          <p:cNvSpPr txBox="1"/>
+          <p:nvPr/>
+        </p:nvSpPr>
+        <p:spPr>
+          <a:xfrm>
+            <a:off x="9349511" y="4846320"/>
+            <a:ext cx="2019224" cy="1188720"/>
+          </a:xfrm>
+          <a:prstGeom prst="rect">
+            <a:avLst/>
+          </a:prstGeom>
+          <a:noFill/>
+          <a:ln/>
+        </p:spPr>
+        <p:txBody>
+          <a:bodyPr wrap="square" lIns="0" tIns="0" rIns="0" bIns="0" rtlCol="0" anchor="t"/>
+          <a:lstStyle/>
+          <a:p>
+            <a:pPr indent="0" marL="0">
+              <a:buNone/>
+            </a:pPr>
+            <a:r>
+              <a:rPr lang="en-US" sz="1400" dirty="0">
+                <a:solidFill>
+                  <a:srgbClr val="3E5068"/>
+                </a:solidFill>
+                <a:latin typeface="Calibri" pitchFamily="34" charset="0"/>
+                <a:ea typeface="Calibri" pitchFamily="34" charset="-122"/>
+                <a:cs typeface="Calibri" pitchFamily="34" charset="-120"/>
+              </a:rPr>
+              <a:t>Bordes de 12 px, sombras suaves, letra Plus Jakarta Sans.</a:t>
+            </a:r>
+            <a:endParaRPr lang="en-US" sz="1400" dirty="0"/>
+          </a:p>
+        </p:txBody>
+      </p:sp>
+    </p:spTree>
+  </p:cSld>
+  <p:clrMapOvr>
+    <a:masterClrMapping/>
+  </p:clrMapOvr>
+</p:sld>
+</file>
+
+<file path=ppt/slides/slide11.xml><?xml version="1.0" encoding="utf-8"?>
+<p:sld xmlns:a="http://schemas.openxmlformats.org/drawingml/2006/main" xmlns:r="http://schemas.openxmlformats.org/officeDocument/2006/relationships" xmlns:p="http://schemas.openxmlformats.org/presentationml/2006/main">
+  <p:cSld name="Slide 11">
+    <p:bg>
+      <p:bgPr>
+        <a:solidFill>
           <a:srgbClr val="EEF3F8"/>
         </a:solidFill>
       </p:bgPr>
@@ -3110,9 +4178,9 @@
 </p:sld>
 </file>
 
-<file path=ppt/slides/slide11.xml><?xml version="1.0" encoding="utf-8"?>
+<file path=ppt/slides/slide12.xml><?xml version="1.0" encoding="utf-8"?>
 <p:sld xmlns:a="http://schemas.openxmlformats.org/drawingml/2006/main" xmlns:r="http://schemas.openxmlformats.org/officeDocument/2006/relationships" xmlns:p="http://schemas.openxmlformats.org/presentationml/2006/main">
-  <p:cSld name="Slide 11">
+  <p:cSld name="Slide 12">
     <p:bg>
       <p:bgPr>
         <a:solidFill>
@@ -10043,7 +11111,7 @@
     <p:bg>
       <p:bgPr>
         <a:solidFill>
-          <a:srgbClr val="F8F9FA"/>
+          <a:srgbClr val="1D3557"/>
         </a:solidFill>
       </p:bgPr>
     </p:bg>
@@ -10069,8 +11137,8 @@
         </p:nvSpPr>
         <p:spPr>
           <a:xfrm>
-            <a:off x="548640" y="411480"/>
-            <a:ext cx="11094415" cy="274320"/>
+            <a:off x="548640" y="1234440"/>
+            <a:ext cx="6309360" cy="320040"/>
           </a:xfrm>
           <a:prstGeom prst="rect">
             <a:avLst/>
@@ -10086,17 +11154,17 @@
               <a:buNone/>
             </a:pPr>
             <a:r>
-              <a:rPr lang="en-US" sz="1200" b="1" spc="200" kern="0" dirty="0">
-                <a:solidFill>
-                  <a:srgbClr val="0077B6"/>
-                </a:solidFill>
-                <a:latin typeface="Calibri" pitchFamily="34" charset="0"/>
-                <a:ea typeface="Calibri" pitchFamily="34" charset="-122"/>
-                <a:cs typeface="Calibri" pitchFamily="34" charset="-120"/>
-              </a:rPr>
-              <a:t>IDENTIDAD VISUAL</a:t>
-            </a:r>
-            <a:endParaRPr lang="en-US" sz="1200" dirty="0"/>
+              <a:rPr lang="en-US" sz="1300" b="1" spc="300" kern="0" dirty="0">
+                <a:solidFill>
+                  <a:srgbClr val="F77F00"/>
+                </a:solidFill>
+                <a:latin typeface="Calibri" pitchFamily="34" charset="0"/>
+                <a:ea typeface="Calibri" pitchFamily="34" charset="-122"/>
+                <a:cs typeface="Calibri" pitchFamily="34" charset="-120"/>
+              </a:rPr>
+              <a:t>MÍRALO EN TU CELULAR</a:t>
+            </a:r>
+            <a:endParaRPr lang="en-US" sz="1300" dirty="0"/>
           </a:p>
         </p:txBody>
       </p:sp>
@@ -10108,8 +11176,8 @@
         </p:nvSpPr>
         <p:spPr>
           <a:xfrm>
-            <a:off x="548640" y="731520"/>
-            <a:ext cx="11094415" cy="914400"/>
+            <a:off x="548640" y="1645920"/>
+            <a:ext cx="6309360" cy="1645920"/>
           </a:xfrm>
           <a:prstGeom prst="rect">
             <a:avLst/>
@@ -10125,454 +11193,170 @@
               <a:buNone/>
             </a:pPr>
             <a:r>
-              <a:rPr lang="en-US" sz="3200" b="1" dirty="0">
-                <a:solidFill>
-                  <a:srgbClr val="1D3557"/>
-                </a:solidFill>
-                <a:latin typeface="Calibri" pitchFamily="34" charset="0"/>
-                <a:ea typeface="Calibri" pitchFamily="34" charset="-122"/>
-                <a:cs typeface="Calibri" pitchFamily="34" charset="-120"/>
-              </a:rPr>
-              <a:t>Colores de Cartagena, pensada para el celular</a:t>
-            </a:r>
-            <a:endParaRPr lang="en-US" sz="3200" dirty="0"/>
-          </a:p>
-        </p:txBody>
-      </p:sp>
-      <p:sp>
-        <p:nvSpPr>
-          <p:cNvPr id="4" name="color-1"/>
+              <a:rPr lang="en-US" sz="4000" b="1" dirty="0">
+                <a:solidFill>
+                  <a:srgbClr val="F8F9FA"/>
+                </a:solidFill>
+                <a:latin typeface="Calibri" pitchFamily="34" charset="0"/>
+                <a:ea typeface="Calibri" pitchFamily="34" charset="-122"/>
+                <a:cs typeface="Calibri" pitchFamily="34" charset="-120"/>
+              </a:rPr>
+              <a:t>Escanea el código y recorre el esqueleto</a:t>
+            </a:r>
+            <a:endParaRPr lang="en-US" sz="4000" dirty="0"/>
+          </a:p>
+        </p:txBody>
+      </p:sp>
+      <p:sp>
+        <p:nvSpPr>
+          <p:cNvPr id="4" name="Text 2">
+            <a:hlinkClick r:id="rId1" tooltip=""/>
+          </p:cNvPr>
+          <p:cNvSpPr txBox="1"/>
+          <p:nvPr/>
+        </p:nvSpPr>
+        <p:spPr>
+          <a:xfrm>
+            <a:off x="548640" y="3429000"/>
+            <a:ext cx="6309360" cy="548640"/>
+          </a:xfrm>
+          <a:prstGeom prst="rect">
+            <a:avLst/>
+          </a:prstGeom>
+          <a:noFill/>
+          <a:ln/>
+        </p:spPr>
+        <p:txBody>
+          <a:bodyPr wrap="square" lIns="0" tIns="0" rIns="0" bIns="0" rtlCol="0" anchor="t"/>
+          <a:lstStyle/>
+          <a:p>
+            <a:pPr indent="0" marL="0">
+              <a:buNone/>
+            </a:pPr>
+            <a:r>
+              <a:rPr lang="en-US" sz="2600" b="1" u="sng" dirty="0">
+                <a:solidFill>
+                  <a:srgbClr val="F77F00"/>
+                </a:solidFill>
+                <a:latin typeface="Calibri" pitchFamily="34" charset="0"/>
+                <a:ea typeface="Calibri" pitchFamily="34" charset="-122"/>
+                <a:cs typeface="Calibri" pitchFamily="34" charset="-120"/>
+                <a:hlinkClick r:id="rId1" invalidUrl="" action="" tgtFrame="" tooltip="" history="1" highlightClick="0" endSnd="0">
+                  <a:extLst>
+                    <a:ext uri="{A12FA001-AC4F-418D-AE19-62706E023703}">
+                      <ahyp:hlinkClr xmlns:ahyp="http://schemas.microsoft.com/office/drawing/2018/hyperlinkcolor" val="tx"/>
+                    </a:ext>
+                  </a:extLst>
+                </a:hlinkClick>
+              </a:rPr>
+              <a:t>cartaviva-ten.vercel.app</a:t>
+            </a:r>
+            <a:endParaRPr lang="en-US" sz="2600" dirty="0"/>
+          </a:p>
+        </p:txBody>
+      </p:sp>
+      <p:sp>
+        <p:nvSpPr>
+          <p:cNvPr id="5" name="Text 3"/>
+          <p:cNvSpPr txBox="1"/>
+          <p:nvPr/>
+        </p:nvSpPr>
+        <p:spPr>
+          <a:xfrm>
+            <a:off x="548640" y="4206240"/>
+            <a:ext cx="6309360" cy="1645920"/>
+          </a:xfrm>
+          <a:prstGeom prst="rect">
+            <a:avLst/>
+          </a:prstGeom>
+          <a:noFill/>
+          <a:ln/>
+        </p:spPr>
+        <p:txBody>
+          <a:bodyPr wrap="square" lIns="0" tIns="0" rIns="0" bIns="0" rtlCol="0" anchor="t"/>
+          <a:lstStyle/>
+          <a:p>
+            <a:pPr marL="342900" indent="-342900">
+              <a:spcAft>
+                <a:spcPts val="800"/>
+              </a:spcAft>
+              <a:buSzPct val="100000"/>
+              <a:buFont typeface="+mj-lt"/>
+              <a:buAutoNum type="arabicPeriod" startAt="1"/>
+            </a:pPr>
+            <a:r>
+              <a:rPr lang="en-US" sz="1800" dirty="0">
+                <a:solidFill>
+                  <a:srgbClr val="DCE6F0"/>
+                </a:solidFill>
+                <a:latin typeface="Calibri" pitchFamily="34" charset="0"/>
+                <a:ea typeface="Calibri" pitchFamily="34" charset="-122"/>
+                <a:cs typeface="Calibri" pitchFamily="34" charset="-120"/>
+              </a:rPr>
+              <a:t>Abre la cámara del celular</a:t>
+            </a:r>
+            <a:endParaRPr lang="en-US" sz="1800" dirty="0"/>
+          </a:p>
+          <a:p>
+            <a:pPr marL="342900" indent="-342900">
+              <a:spcAft>
+                <a:spcPts val="800"/>
+              </a:spcAft>
+              <a:buSzPct val="100000"/>
+              <a:buFont typeface="+mj-lt"/>
+              <a:buAutoNum type="arabicPeriod" startAt="1"/>
+            </a:pPr>
+            <a:r>
+              <a:rPr lang="en-US" sz="1800" dirty="0">
+                <a:solidFill>
+                  <a:srgbClr val="DCE6F0"/>
+                </a:solidFill>
+                <a:latin typeface="Calibri" pitchFamily="34" charset="0"/>
+                <a:ea typeface="Calibri" pitchFamily="34" charset="-122"/>
+                <a:cs typeface="Calibri" pitchFamily="34" charset="-120"/>
+              </a:rPr>
+              <a:t>Apunta a este código</a:t>
+            </a:r>
+            <a:endParaRPr lang="en-US" sz="1800" dirty="0"/>
+          </a:p>
+          <a:p>
+            <a:pPr marL="342900" indent="-342900">
+              <a:spcAft>
+                <a:spcPts val="800"/>
+              </a:spcAft>
+              <a:buSzPct val="100000"/>
+              <a:buFont typeface="+mj-lt"/>
+              <a:buAutoNum type="arabicPeriod" startAt="1"/>
+            </a:pPr>
+            <a:r>
+              <a:rPr lang="en-US" sz="1800" dirty="0">
+                <a:solidFill>
+                  <a:srgbClr val="DCE6F0"/>
+                </a:solidFill>
+                <a:latin typeface="Calibri" pitchFamily="34" charset="0"/>
+                <a:ea typeface="Calibri" pitchFamily="34" charset="-122"/>
+                <a:cs typeface="Calibri" pitchFamily="34" charset="-120"/>
+              </a:rPr>
+              <a:t>Toca el enlace y elige una pantalla</a:t>
+            </a:r>
+            <a:endParaRPr lang="en-US" sz="1800" dirty="0"/>
+          </a:p>
+        </p:txBody>
+      </p:sp>
+      <p:sp>
+        <p:nvSpPr>
+          <p:cNvPr id="6" name="marco-qr"/>
           <p:cNvSpPr/>
           <p:nvPr/>
         </p:nvSpPr>
         <p:spPr>
           <a:xfrm>
-            <a:off x="548640" y="1828800"/>
-            <a:ext cx="2567864" cy="1188720"/>
+            <a:off x="7452360" y="1051560"/>
+            <a:ext cx="4206240" cy="4206240"/>
           </a:xfrm>
           <a:prstGeom prst="roundRect">
             <a:avLst>
-              <a:gd name="adj" fmla="val 9231"/>
-            </a:avLst>
-          </a:prstGeom>
-          <a:solidFill>
-            <a:srgbClr val="0077B6"/>
-          </a:solidFill>
-          <a:ln w="12700">
-            <a:solidFill>
-              <a:srgbClr val="0077B6"/>
-            </a:solidFill>
-            <a:prstDash val="solid"/>
-          </a:ln>
-        </p:spPr>
-      </p:sp>
-      <p:sp>
-        <p:nvSpPr>
-          <p:cNvPr id="5" name="Text 3"/>
-          <p:cNvSpPr txBox="1"/>
-          <p:nvPr/>
-        </p:nvSpPr>
-        <p:spPr>
-          <a:xfrm>
-            <a:off x="548640" y="3127248"/>
-            <a:ext cx="2567864" cy="365760"/>
-          </a:xfrm>
-          <a:prstGeom prst="rect">
-            <a:avLst/>
-          </a:prstGeom>
-          <a:noFill/>
-          <a:ln/>
-        </p:spPr>
-        <p:txBody>
-          <a:bodyPr wrap="square" lIns="0" tIns="0" rIns="0" bIns="0" rtlCol="0" anchor="t"/>
-          <a:lstStyle/>
-          <a:p>
-            <a:pPr indent="0" marL="0">
-              <a:buNone/>
-            </a:pPr>
-            <a:r>
-              <a:rPr lang="en-US" sz="1600" b="1" dirty="0">
-                <a:solidFill>
-                  <a:srgbClr val="1D3557"/>
-                </a:solidFill>
-                <a:latin typeface="Calibri" pitchFamily="34" charset="0"/>
-                <a:ea typeface="Calibri" pitchFamily="34" charset="-122"/>
-                <a:cs typeface="Calibri" pitchFamily="34" charset="-120"/>
-              </a:rPr>
-              <a:t>Azul Caribe</a:t>
-            </a:r>
-            <a:endParaRPr lang="en-US" sz="1600" dirty="0"/>
-          </a:p>
-        </p:txBody>
-      </p:sp>
-      <p:sp>
-        <p:nvSpPr>
-          <p:cNvPr id="6" name="Text 4"/>
-          <p:cNvSpPr txBox="1"/>
-          <p:nvPr/>
-        </p:nvSpPr>
-        <p:spPr>
-          <a:xfrm>
-            <a:off x="548640" y="3474720"/>
-            <a:ext cx="2567864" cy="320040"/>
-          </a:xfrm>
-          <a:prstGeom prst="rect">
-            <a:avLst/>
-          </a:prstGeom>
-          <a:noFill/>
-          <a:ln/>
-        </p:spPr>
-        <p:txBody>
-          <a:bodyPr wrap="square" lIns="0" tIns="0" rIns="0" bIns="0" rtlCol="0" anchor="t"/>
-          <a:lstStyle/>
-          <a:p>
-            <a:pPr indent="0" marL="0">
-              <a:buNone/>
-            </a:pPr>
-            <a:r>
-              <a:rPr lang="en-US" sz="1200" dirty="0">
-                <a:solidFill>
-                  <a:srgbClr val="4A5B70"/>
-                </a:solidFill>
-                <a:latin typeface="Calibri" pitchFamily="34" charset="0"/>
-                <a:ea typeface="Calibri" pitchFamily="34" charset="-122"/>
-                <a:cs typeface="Calibri" pitchFamily="34" charset="-120"/>
-              </a:rPr>
-              <a:t>#0077B6 · acciones</a:t>
-            </a:r>
-            <a:endParaRPr lang="en-US" sz="1200" dirty="0"/>
-          </a:p>
-        </p:txBody>
-      </p:sp>
-      <p:sp>
-        <p:nvSpPr>
-          <p:cNvPr id="7" name="color-2"/>
-          <p:cNvSpPr/>
-          <p:nvPr/>
-        </p:nvSpPr>
-        <p:spPr>
-          <a:xfrm>
-            <a:off x="3390824" y="1828800"/>
-            <a:ext cx="2567864" cy="1188720"/>
-          </a:xfrm>
-          <a:prstGeom prst="roundRect">
-            <a:avLst>
-              <a:gd name="adj" fmla="val 9231"/>
-            </a:avLst>
-          </a:prstGeom>
-          <a:solidFill>
-            <a:srgbClr val="F77F00"/>
-          </a:solidFill>
-          <a:ln w="12700">
-            <a:solidFill>
-              <a:srgbClr val="F77F00"/>
-            </a:solidFill>
-            <a:prstDash val="solid"/>
-          </a:ln>
-        </p:spPr>
-      </p:sp>
-      <p:sp>
-        <p:nvSpPr>
-          <p:cNvPr id="8" name="Text 6"/>
-          <p:cNvSpPr txBox="1"/>
-          <p:nvPr/>
-        </p:nvSpPr>
-        <p:spPr>
-          <a:xfrm>
-            <a:off x="3390824" y="3127248"/>
-            <a:ext cx="2567864" cy="365760"/>
-          </a:xfrm>
-          <a:prstGeom prst="rect">
-            <a:avLst/>
-          </a:prstGeom>
-          <a:noFill/>
-          <a:ln/>
-        </p:spPr>
-        <p:txBody>
-          <a:bodyPr wrap="square" lIns="0" tIns="0" rIns="0" bIns="0" rtlCol="0" anchor="t"/>
-          <a:lstStyle/>
-          <a:p>
-            <a:pPr indent="0" marL="0">
-              <a:buNone/>
-            </a:pPr>
-            <a:r>
-              <a:rPr lang="en-US" sz="1600" b="1" dirty="0">
-                <a:solidFill>
-                  <a:srgbClr val="1D3557"/>
-                </a:solidFill>
-                <a:latin typeface="Calibri" pitchFamily="34" charset="0"/>
-                <a:ea typeface="Calibri" pitchFamily="34" charset="-122"/>
-                <a:cs typeface="Calibri" pitchFamily="34" charset="-120"/>
-              </a:rPr>
-              <a:t>Amarillo Sol</a:t>
-            </a:r>
-            <a:endParaRPr lang="en-US" sz="1600" dirty="0"/>
-          </a:p>
-        </p:txBody>
-      </p:sp>
-      <p:sp>
-        <p:nvSpPr>
-          <p:cNvPr id="9" name="Text 7"/>
-          <p:cNvSpPr txBox="1"/>
-          <p:nvPr/>
-        </p:nvSpPr>
-        <p:spPr>
-          <a:xfrm>
-            <a:off x="3390824" y="3474720"/>
-            <a:ext cx="2567864" cy="320040"/>
-          </a:xfrm>
-          <a:prstGeom prst="rect">
-            <a:avLst/>
-          </a:prstGeom>
-          <a:noFill/>
-          <a:ln/>
-        </p:spPr>
-        <p:txBody>
-          <a:bodyPr wrap="square" lIns="0" tIns="0" rIns="0" bIns="0" rtlCol="0" anchor="t"/>
-          <a:lstStyle/>
-          <a:p>
-            <a:pPr indent="0" marL="0">
-              <a:buNone/>
-            </a:pPr>
-            <a:r>
-              <a:rPr lang="en-US" sz="1200" dirty="0">
-                <a:solidFill>
-                  <a:srgbClr val="4A5B70"/>
-                </a:solidFill>
-                <a:latin typeface="Calibri" pitchFamily="34" charset="0"/>
-                <a:ea typeface="Calibri" pitchFamily="34" charset="-122"/>
-                <a:cs typeface="Calibri" pitchFamily="34" charset="-120"/>
-              </a:rPr>
-              <a:t>#F77F00 · destacados</a:t>
-            </a:r>
-            <a:endParaRPr lang="en-US" sz="1200" dirty="0"/>
-          </a:p>
-        </p:txBody>
-      </p:sp>
-      <p:sp>
-        <p:nvSpPr>
-          <p:cNvPr id="10" name="color-3"/>
-          <p:cNvSpPr/>
-          <p:nvPr/>
-        </p:nvSpPr>
-        <p:spPr>
-          <a:xfrm>
-            <a:off x="6233008" y="1828800"/>
-            <a:ext cx="2567864" cy="1188720"/>
-          </a:xfrm>
-          <a:prstGeom prst="roundRect">
-            <a:avLst>
-              <a:gd name="adj" fmla="val 9231"/>
-            </a:avLst>
-          </a:prstGeom>
-          <a:solidFill>
-            <a:srgbClr val="1D3557"/>
-          </a:solidFill>
-          <a:ln w="12700">
-            <a:solidFill>
-              <a:srgbClr val="1D3557"/>
-            </a:solidFill>
-            <a:prstDash val="solid"/>
-          </a:ln>
-        </p:spPr>
-      </p:sp>
-      <p:sp>
-        <p:nvSpPr>
-          <p:cNvPr id="11" name="Text 9"/>
-          <p:cNvSpPr txBox="1"/>
-          <p:nvPr/>
-        </p:nvSpPr>
-        <p:spPr>
-          <a:xfrm>
-            <a:off x="6233008" y="3127248"/>
-            <a:ext cx="2567864" cy="365760"/>
-          </a:xfrm>
-          <a:prstGeom prst="rect">
-            <a:avLst/>
-          </a:prstGeom>
-          <a:noFill/>
-          <a:ln/>
-        </p:spPr>
-        <p:txBody>
-          <a:bodyPr wrap="square" lIns="0" tIns="0" rIns="0" bIns="0" rtlCol="0" anchor="t"/>
-          <a:lstStyle/>
-          <a:p>
-            <a:pPr indent="0" marL="0">
-              <a:buNone/>
-            </a:pPr>
-            <a:r>
-              <a:rPr lang="en-US" sz="1600" b="1" dirty="0">
-                <a:solidFill>
-                  <a:srgbClr val="1D3557"/>
-                </a:solidFill>
-                <a:latin typeface="Calibri" pitchFamily="34" charset="0"/>
-                <a:ea typeface="Calibri" pitchFamily="34" charset="-122"/>
-                <a:cs typeface="Calibri" pitchFamily="34" charset="-120"/>
-              </a:rPr>
-              <a:t>Colonial Dark</a:t>
-            </a:r>
-            <a:endParaRPr lang="en-US" sz="1600" dirty="0"/>
-          </a:p>
-        </p:txBody>
-      </p:sp>
-      <p:sp>
-        <p:nvSpPr>
-          <p:cNvPr id="12" name="Text 10"/>
-          <p:cNvSpPr txBox="1"/>
-          <p:nvPr/>
-        </p:nvSpPr>
-        <p:spPr>
-          <a:xfrm>
-            <a:off x="6233008" y="3474720"/>
-            <a:ext cx="2567864" cy="320040"/>
-          </a:xfrm>
-          <a:prstGeom prst="rect">
-            <a:avLst/>
-          </a:prstGeom>
-          <a:noFill/>
-          <a:ln/>
-        </p:spPr>
-        <p:txBody>
-          <a:bodyPr wrap="square" lIns="0" tIns="0" rIns="0" bIns="0" rtlCol="0" anchor="t"/>
-          <a:lstStyle/>
-          <a:p>
-            <a:pPr indent="0" marL="0">
-              <a:buNone/>
-            </a:pPr>
-            <a:r>
-              <a:rPr lang="en-US" sz="1200" dirty="0">
-                <a:solidFill>
-                  <a:srgbClr val="4A5B70"/>
-                </a:solidFill>
-                <a:latin typeface="Calibri" pitchFamily="34" charset="0"/>
-                <a:ea typeface="Calibri" pitchFamily="34" charset="-122"/>
-                <a:cs typeface="Calibri" pitchFamily="34" charset="-120"/>
-              </a:rPr>
-              <a:t>#1D3557 · texto</a:t>
-            </a:r>
-            <a:endParaRPr lang="en-US" sz="1200" dirty="0"/>
-          </a:p>
-        </p:txBody>
-      </p:sp>
-      <p:sp>
-        <p:nvSpPr>
-          <p:cNvPr id="13" name="color-4"/>
-          <p:cNvSpPr/>
-          <p:nvPr/>
-        </p:nvSpPr>
-        <p:spPr>
-          <a:xfrm>
-            <a:off x="9075191" y="1828800"/>
-            <a:ext cx="2567864" cy="1188720"/>
-          </a:xfrm>
-          <a:prstGeom prst="roundRect">
-            <a:avLst>
-              <a:gd name="adj" fmla="val 9231"/>
-            </a:avLst>
-          </a:prstGeom>
-          <a:solidFill>
-            <a:srgbClr val="F8F9FA"/>
-          </a:solidFill>
-          <a:ln w="12700">
-            <a:solidFill>
-              <a:srgbClr val="C9D4DF"/>
-            </a:solidFill>
-            <a:prstDash val="solid"/>
-          </a:ln>
-        </p:spPr>
-      </p:sp>
-      <p:sp>
-        <p:nvSpPr>
-          <p:cNvPr id="14" name="Text 12"/>
-          <p:cNvSpPr txBox="1"/>
-          <p:nvPr/>
-        </p:nvSpPr>
-        <p:spPr>
-          <a:xfrm>
-            <a:off x="9075191" y="3127248"/>
-            <a:ext cx="2567864" cy="365760"/>
-          </a:xfrm>
-          <a:prstGeom prst="rect">
-            <a:avLst/>
-          </a:prstGeom>
-          <a:noFill/>
-          <a:ln/>
-        </p:spPr>
-        <p:txBody>
-          <a:bodyPr wrap="square" lIns="0" tIns="0" rIns="0" bIns="0" rtlCol="0" anchor="t"/>
-          <a:lstStyle/>
-          <a:p>
-            <a:pPr indent="0" marL="0">
-              <a:buNone/>
-            </a:pPr>
-            <a:r>
-              <a:rPr lang="en-US" sz="1600" b="1" dirty="0">
-                <a:solidFill>
-                  <a:srgbClr val="1D3557"/>
-                </a:solidFill>
-                <a:latin typeface="Calibri" pitchFamily="34" charset="0"/>
-                <a:ea typeface="Calibri" pitchFamily="34" charset="-122"/>
-                <a:cs typeface="Calibri" pitchFamily="34" charset="-120"/>
-              </a:rPr>
-              <a:t>Blanco Arena</a:t>
-            </a:r>
-            <a:endParaRPr lang="en-US" sz="1600" dirty="0"/>
-          </a:p>
-        </p:txBody>
-      </p:sp>
-      <p:sp>
-        <p:nvSpPr>
-          <p:cNvPr id="15" name="Text 13"/>
-          <p:cNvSpPr txBox="1"/>
-          <p:nvPr/>
-        </p:nvSpPr>
-        <p:spPr>
-          <a:xfrm>
-            <a:off x="9075191" y="3474720"/>
-            <a:ext cx="2567864" cy="320040"/>
-          </a:xfrm>
-          <a:prstGeom prst="rect">
-            <a:avLst/>
-          </a:prstGeom>
-          <a:noFill/>
-          <a:ln/>
-        </p:spPr>
-        <p:txBody>
-          <a:bodyPr wrap="square" lIns="0" tIns="0" rIns="0" bIns="0" rtlCol="0" anchor="t"/>
-          <a:lstStyle/>
-          <a:p>
-            <a:pPr indent="0" marL="0">
-              <a:buNone/>
-            </a:pPr>
-            <a:r>
-              <a:rPr lang="en-US" sz="1200" dirty="0">
-                <a:solidFill>
-                  <a:srgbClr val="4A5B70"/>
-                </a:solidFill>
-                <a:latin typeface="Calibri" pitchFamily="34" charset="0"/>
-                <a:ea typeface="Calibri" pitchFamily="34" charset="-122"/>
-                <a:cs typeface="Calibri" pitchFamily="34" charset="-120"/>
-              </a:rPr>
-              <a:t>#F8F9FA · fondo</a:t>
-            </a:r>
-            <a:endParaRPr lang="en-US" sz="1200" dirty="0"/>
-          </a:p>
-        </p:txBody>
-      </p:sp>
-      <p:sp>
-        <p:nvSpPr>
-          <p:cNvPr id="16" name="regla-1"/>
-          <p:cNvSpPr/>
-          <p:nvPr/>
-        </p:nvSpPr>
-        <p:spPr>
-          <a:xfrm>
-            <a:off x="548640" y="4160520"/>
-            <a:ext cx="2567864" cy="2011680"/>
-          </a:xfrm>
-          <a:prstGeom prst="roundRect">
-            <a:avLst>
-              <a:gd name="adj" fmla="val 5455"/>
+              <a:gd name="adj" fmla="val 4348"/>
             </a:avLst>
           </a:prstGeom>
           <a:solidFill>
@@ -10585,428 +11369,38 @@
             <a:prstDash val="solid"/>
           </a:ln>
           <a:effectLst>
-            <a:outerShdw sx="100000" sy="100000" kx="0" ky="0" algn="bl" rotWithShape="0" blurRad="101600" dist="25400" dir="5400000">
-              <a:srgbClr val="1D3557">
-                <a:alpha val="12000"/>
+            <a:outerShdw sx="100000" sy="100000" kx="0" ky="0" algn="bl" rotWithShape="0" blurRad="254000" dist="76200" dir="5400000">
+              <a:srgbClr val="000000">
+                <a:alpha val="35000"/>
               </a:srgbClr>
             </a:outerShdw>
           </a:effectLst>
         </p:spPr>
       </p:sp>
-      <p:sp>
-        <p:nvSpPr>
-          <p:cNvPr id="17" name="Text 15"/>
-          <p:cNvSpPr txBox="1"/>
-          <p:nvPr/>
-        </p:nvSpPr>
-        <p:spPr>
-          <a:xfrm>
-            <a:off x="822960" y="4389120"/>
-            <a:ext cx="2019224" cy="411480"/>
-          </a:xfrm>
-          <a:prstGeom prst="rect">
-            <a:avLst/>
-          </a:prstGeom>
-          <a:noFill/>
-          <a:ln/>
-        </p:spPr>
-        <p:txBody>
-          <a:bodyPr wrap="square" lIns="0" tIns="0" rIns="0" bIns="0" rtlCol="0" anchor="t"/>
-          <a:lstStyle/>
-          <a:p>
-            <a:pPr indent="0" marL="0">
-              <a:buNone/>
-            </a:pPr>
-            <a:r>
-              <a:rPr lang="en-US" sz="1800" b="1" dirty="0">
-                <a:solidFill>
-                  <a:srgbClr val="1D3557"/>
-                </a:solidFill>
-                <a:latin typeface="Calibri" pitchFamily="34" charset="0"/>
-                <a:ea typeface="Calibri" pitchFamily="34" charset="-122"/>
-                <a:cs typeface="Calibri" pitchFamily="34" charset="-120"/>
-              </a:rPr>
-              <a:t>Mobile-first</a:t>
-            </a:r>
-            <a:endParaRPr lang="en-US" sz="1800" dirty="0"/>
-          </a:p>
-        </p:txBody>
-      </p:sp>
-      <p:sp>
-        <p:nvSpPr>
-          <p:cNvPr id="18" name="Text 16"/>
-          <p:cNvSpPr txBox="1"/>
-          <p:nvPr/>
-        </p:nvSpPr>
-        <p:spPr>
-          <a:xfrm>
-            <a:off x="822960" y="4846320"/>
-            <a:ext cx="2019224" cy="1188720"/>
-          </a:xfrm>
-          <a:prstGeom prst="rect">
-            <a:avLst/>
-          </a:prstGeom>
-          <a:noFill/>
-          <a:ln/>
-        </p:spPr>
-        <p:txBody>
-          <a:bodyPr wrap="square" lIns="0" tIns="0" rIns="0" bIns="0" rtlCol="0" anchor="t"/>
-          <a:lstStyle/>
-          <a:p>
-            <a:pPr indent="0" marL="0">
-              <a:buNone/>
-            </a:pPr>
-            <a:r>
-              <a:rPr lang="en-US" sz="1400" dirty="0">
-                <a:solidFill>
-                  <a:srgbClr val="3E5068"/>
-                </a:solidFill>
-                <a:latin typeface="Calibri" pitchFamily="34" charset="0"/>
-                <a:ea typeface="Calibri" pitchFamily="34" charset="-122"/>
-                <a:cs typeface="Calibri" pitchFamily="34" charset="-120"/>
-              </a:rPr>
-              <a:t>Pantallas de 390 px; botones de 44 px o más.</a:t>
-            </a:r>
-            <a:endParaRPr lang="en-US" sz="1400" dirty="0"/>
-          </a:p>
-        </p:txBody>
-      </p:sp>
-      <p:sp>
-        <p:nvSpPr>
-          <p:cNvPr id="19" name="regla-2"/>
-          <p:cNvSpPr/>
-          <p:nvPr/>
-        </p:nvSpPr>
-        <p:spPr>
-          <a:xfrm>
-            <a:off x="3390824" y="4160520"/>
-            <a:ext cx="2567864" cy="2011680"/>
-          </a:xfrm>
-          <a:prstGeom prst="roundRect">
-            <a:avLst>
-              <a:gd name="adj" fmla="val 5455"/>
-            </a:avLst>
-          </a:prstGeom>
-          <a:solidFill>
-            <a:srgbClr val="FFFFFF"/>
-          </a:solidFill>
-          <a:ln w="12700">
-            <a:solidFill>
-              <a:srgbClr val="FFFFFF"/>
-            </a:solidFill>
-            <a:prstDash val="solid"/>
-          </a:ln>
-          <a:effectLst>
-            <a:outerShdw sx="100000" sy="100000" kx="0" ky="0" algn="bl" rotWithShape="0" blurRad="101600" dist="25400" dir="5400000">
-              <a:srgbClr val="1D3557">
-                <a:alpha val="12000"/>
-              </a:srgbClr>
-            </a:outerShdw>
-          </a:effectLst>
-        </p:spPr>
-      </p:sp>
-      <p:sp>
-        <p:nvSpPr>
-          <p:cNvPr id="20" name="Text 18"/>
-          <p:cNvSpPr txBox="1"/>
-          <p:nvPr/>
-        </p:nvSpPr>
-        <p:spPr>
-          <a:xfrm>
-            <a:off x="3665144" y="4389120"/>
-            <a:ext cx="2019224" cy="411480"/>
-          </a:xfrm>
-          <a:prstGeom prst="rect">
-            <a:avLst/>
-          </a:prstGeom>
-          <a:noFill/>
-          <a:ln/>
-        </p:spPr>
-        <p:txBody>
-          <a:bodyPr wrap="square" lIns="0" tIns="0" rIns="0" bIns="0" rtlCol="0" anchor="t"/>
-          <a:lstStyle/>
-          <a:p>
-            <a:pPr indent="0" marL="0">
-              <a:buNone/>
-            </a:pPr>
-            <a:r>
-              <a:rPr lang="en-US" sz="1800" b="1" dirty="0">
-                <a:solidFill>
-                  <a:srgbClr val="1D3557"/>
-                </a:solidFill>
-                <a:latin typeface="Calibri" pitchFamily="34" charset="0"/>
-                <a:ea typeface="Calibri" pitchFamily="34" charset="-122"/>
-                <a:cs typeface="Calibri" pitchFamily="34" charset="-120"/>
-              </a:rPr>
-              <a:t>Contraste AA</a:t>
-            </a:r>
-            <a:endParaRPr lang="en-US" sz="1800" dirty="0"/>
-          </a:p>
-        </p:txBody>
-      </p:sp>
-      <p:sp>
-        <p:nvSpPr>
-          <p:cNvPr id="21" name="Text 19"/>
-          <p:cNvSpPr txBox="1"/>
-          <p:nvPr/>
-        </p:nvSpPr>
-        <p:spPr>
-          <a:xfrm>
-            <a:off x="3665144" y="4846320"/>
-            <a:ext cx="2019224" cy="1188720"/>
-          </a:xfrm>
-          <a:prstGeom prst="rect">
-            <a:avLst/>
-          </a:prstGeom>
-          <a:noFill/>
-          <a:ln/>
-        </p:spPr>
-        <p:txBody>
-          <a:bodyPr wrap="square" lIns="0" tIns="0" rIns="0" bIns="0" rtlCol="0" anchor="t"/>
-          <a:lstStyle/>
-          <a:p>
-            <a:pPr indent="0" marL="0">
-              <a:buNone/>
-            </a:pPr>
-            <a:r>
-              <a:rPr lang="en-US" sz="1400" dirty="0">
-                <a:solidFill>
-                  <a:srgbClr val="3E5068"/>
-                </a:solidFill>
-                <a:latin typeface="Calibri" pitchFamily="34" charset="0"/>
-                <a:ea typeface="Calibri" pitchFamily="34" charset="-122"/>
-                <a:cs typeface="Calibri" pitchFamily="34" charset="-120"/>
-              </a:rPr>
-              <a:t>Texto con 4,5:1 o más sobre su fondo (WCAG).</a:t>
-            </a:r>
-            <a:endParaRPr lang="en-US" sz="1400" dirty="0"/>
-          </a:p>
-        </p:txBody>
-      </p:sp>
-      <p:sp>
-        <p:nvSpPr>
-          <p:cNvPr id="22" name="regla-3"/>
-          <p:cNvSpPr/>
-          <p:nvPr/>
-        </p:nvSpPr>
-        <p:spPr>
-          <a:xfrm>
-            <a:off x="6233008" y="4160520"/>
-            <a:ext cx="2567864" cy="2011680"/>
-          </a:xfrm>
-          <a:prstGeom prst="roundRect">
-            <a:avLst>
-              <a:gd name="adj" fmla="val 5455"/>
-            </a:avLst>
-          </a:prstGeom>
-          <a:solidFill>
-            <a:srgbClr val="FFFFFF"/>
-          </a:solidFill>
-          <a:ln w="12700">
-            <a:solidFill>
-              <a:srgbClr val="FFFFFF"/>
-            </a:solidFill>
-            <a:prstDash val="solid"/>
-          </a:ln>
-          <a:effectLst>
-            <a:outerShdw sx="100000" sy="100000" kx="0" ky="0" algn="bl" rotWithShape="0" blurRad="101600" dist="25400" dir="5400000">
-              <a:srgbClr val="1D3557">
-                <a:alpha val="12000"/>
-              </a:srgbClr>
-            </a:outerShdw>
-          </a:effectLst>
-        </p:spPr>
-      </p:sp>
-      <p:sp>
-        <p:nvSpPr>
-          <p:cNvPr id="23" name="Text 21"/>
-          <p:cNvSpPr txBox="1"/>
-          <p:nvPr/>
-        </p:nvSpPr>
-        <p:spPr>
-          <a:xfrm>
-            <a:off x="6507328" y="4389120"/>
-            <a:ext cx="2019224" cy="411480"/>
-          </a:xfrm>
-          <a:prstGeom prst="rect">
-            <a:avLst/>
-          </a:prstGeom>
-          <a:noFill/>
-          <a:ln/>
-        </p:spPr>
-        <p:txBody>
-          <a:bodyPr wrap="square" lIns="0" tIns="0" rIns="0" bIns="0" rtlCol="0" anchor="t"/>
-          <a:lstStyle/>
-          <a:p>
-            <a:pPr indent="0" marL="0">
-              <a:buNone/>
-            </a:pPr>
-            <a:r>
-              <a:rPr lang="en-US" sz="1800" b="1" dirty="0">
-                <a:solidFill>
-                  <a:srgbClr val="1D3557"/>
-                </a:solidFill>
-                <a:latin typeface="Calibri" pitchFamily="34" charset="0"/>
-                <a:ea typeface="Calibri" pitchFamily="34" charset="-122"/>
-                <a:cs typeface="Calibri" pitchFamily="34" charset="-120"/>
-              </a:rPr>
-              <a:t>Movimiento</a:t>
-            </a:r>
-            <a:endParaRPr lang="en-US" sz="1800" dirty="0"/>
-          </a:p>
-        </p:txBody>
-      </p:sp>
-      <p:sp>
-        <p:nvSpPr>
-          <p:cNvPr id="24" name="Text 22"/>
-          <p:cNvSpPr txBox="1"/>
-          <p:nvPr/>
-        </p:nvSpPr>
-        <p:spPr>
-          <a:xfrm>
-            <a:off x="6507328" y="4846320"/>
-            <a:ext cx="2019224" cy="1188720"/>
-          </a:xfrm>
-          <a:prstGeom prst="rect">
-            <a:avLst/>
-          </a:prstGeom>
-          <a:noFill/>
-          <a:ln/>
-        </p:spPr>
-        <p:txBody>
-          <a:bodyPr wrap="square" lIns="0" tIns="0" rIns="0" bIns="0" rtlCol="0" anchor="t"/>
-          <a:lstStyle/>
-          <a:p>
-            <a:pPr indent="0" marL="0">
-              <a:buNone/>
-            </a:pPr>
-            <a:r>
-              <a:rPr lang="en-US" sz="1400" dirty="0">
-                <a:solidFill>
-                  <a:srgbClr val="3E5068"/>
-                </a:solidFill>
-                <a:latin typeface="Calibri" pitchFamily="34" charset="0"/>
-                <a:ea typeface="Calibri" pitchFamily="34" charset="-122"/>
-                <a:cs typeface="Calibri" pitchFamily="34" charset="-120"/>
-              </a:rPr>
-              <a:t>Transiciones de 200 a 300 ms y skeletons de carga.</a:t>
-            </a:r>
-            <a:endParaRPr lang="en-US" sz="1400" dirty="0"/>
-          </a:p>
-        </p:txBody>
-      </p:sp>
-      <p:sp>
-        <p:nvSpPr>
-          <p:cNvPr id="25" name="regla-4"/>
-          <p:cNvSpPr/>
-          <p:nvPr/>
-        </p:nvSpPr>
-        <p:spPr>
-          <a:xfrm>
-            <a:off x="9075191" y="4160520"/>
-            <a:ext cx="2567864" cy="2011680"/>
-          </a:xfrm>
-          <a:prstGeom prst="roundRect">
-            <a:avLst>
-              <a:gd name="adj" fmla="val 5455"/>
-            </a:avLst>
-          </a:prstGeom>
-          <a:solidFill>
-            <a:srgbClr val="FFFFFF"/>
-          </a:solidFill>
-          <a:ln w="12700">
-            <a:solidFill>
-              <a:srgbClr val="FFFFFF"/>
-            </a:solidFill>
-            <a:prstDash val="solid"/>
-          </a:ln>
-          <a:effectLst>
-            <a:outerShdw sx="100000" sy="100000" kx="0" ky="0" algn="bl" rotWithShape="0" blurRad="101600" dist="25400" dir="5400000">
-              <a:srgbClr val="1D3557">
-                <a:alpha val="12000"/>
-              </a:srgbClr>
-            </a:outerShdw>
-          </a:effectLst>
-        </p:spPr>
-      </p:sp>
-      <p:sp>
-        <p:nvSpPr>
-          <p:cNvPr id="26" name="Text 24"/>
-          <p:cNvSpPr txBox="1"/>
-          <p:nvPr/>
-        </p:nvSpPr>
-        <p:spPr>
-          <a:xfrm>
-            <a:off x="9349511" y="4389120"/>
-            <a:ext cx="2019224" cy="411480"/>
-          </a:xfrm>
-          <a:prstGeom prst="rect">
-            <a:avLst/>
-          </a:prstGeom>
-          <a:noFill/>
-          <a:ln/>
-        </p:spPr>
-        <p:txBody>
-          <a:bodyPr wrap="square" lIns="0" tIns="0" rIns="0" bIns="0" rtlCol="0" anchor="t"/>
-          <a:lstStyle/>
-          <a:p>
-            <a:pPr indent="0" marL="0">
-              <a:buNone/>
-            </a:pPr>
-            <a:r>
-              <a:rPr lang="en-US" sz="1800" b="1" dirty="0">
-                <a:solidFill>
-                  <a:srgbClr val="1D3557"/>
-                </a:solidFill>
-                <a:latin typeface="Calibri" pitchFamily="34" charset="0"/>
-                <a:ea typeface="Calibri" pitchFamily="34" charset="-122"/>
-                <a:cs typeface="Calibri" pitchFamily="34" charset="-120"/>
-              </a:rPr>
-              <a:t>Forma</a:t>
-            </a:r>
-            <a:endParaRPr lang="en-US" sz="1800" dirty="0"/>
-          </a:p>
-        </p:txBody>
-      </p:sp>
-      <p:sp>
-        <p:nvSpPr>
-          <p:cNvPr id="27" name="Text 25"/>
-          <p:cNvSpPr txBox="1"/>
-          <p:nvPr/>
-        </p:nvSpPr>
-        <p:spPr>
-          <a:xfrm>
-            <a:off x="9349511" y="4846320"/>
-            <a:ext cx="2019224" cy="1188720"/>
-          </a:xfrm>
-          <a:prstGeom prst="rect">
-            <a:avLst/>
-          </a:prstGeom>
-          <a:noFill/>
-          <a:ln/>
-        </p:spPr>
-        <p:txBody>
-          <a:bodyPr wrap="square" lIns="0" tIns="0" rIns="0" bIns="0" rtlCol="0" anchor="t"/>
-          <a:lstStyle/>
-          <a:p>
-            <a:pPr indent="0" marL="0">
-              <a:buNone/>
-            </a:pPr>
-            <a:r>
-              <a:rPr lang="en-US" sz="1400" dirty="0">
-                <a:solidFill>
-                  <a:srgbClr val="3E5068"/>
-                </a:solidFill>
-                <a:latin typeface="Calibri" pitchFamily="34" charset="0"/>
-                <a:ea typeface="Calibri" pitchFamily="34" charset="-122"/>
-                <a:cs typeface="Calibri" pitchFamily="34" charset="-120"/>
-              </a:rPr>
-              <a:t>Bordes de 12 px, sombras suaves, letra Plus Jakarta Sans.</a:t>
-            </a:r>
-            <a:endParaRPr lang="en-US" sz="1400" dirty="0"/>
-          </a:p>
-        </p:txBody>
-      </p:sp>
+      <p:pic>
+        <p:nvPicPr>
+          <p:cNvPr id="7" name="qr-esqueleto" descr="Código QR que abre cartaviva-ten.vercel.app">    </p:cNvPr>
+          <p:cNvPicPr>
+            <a:picLocks noChangeAspect="1"/>
+          </p:cNvPicPr>
+          <p:nvPr/>
+        </p:nvPicPr>
+        <p:blipFill>
+          <a:blip r:embed="rId2"/>
+          <a:stretch>
+            <a:fillRect/>
+          </a:stretch>
+        </p:blipFill>
+        <p:spPr>
+          <a:xfrm>
+            <a:off x="7726680" y="1325880"/>
+            <a:ext cx="3657600" cy="3657600"/>
+          </a:xfrm>
+          <a:prstGeom prst="rect">
+            <a:avLst/>
+          </a:prstGeom>
+        </p:spPr>
+      </p:pic>
     </p:spTree>
   </p:cSld>
   <p:clrMapOvr>

</xml_diff>